<commit_message>
v8.2: register and documents moved to legacy CPAT 1.0pre_465
Row map 456->465 and remap tool; fix plans and register sources remapped and
checked against 465; register v8.2 with the status in legacy of every bug
(CPAT team's fixes: Appendix C confirmed, Appendix B caveats / not fixed);
In legacy 465 columns in BUGS.md, LegacyBugFixes.md and the register
spreadsheet; tracker refreshed. Release v8.2 (workbook formulas unchanged:
quick check 0 change vs v8.1, paste test PASS), deck and Word documentation
rebuilt; tidy-up of bugsfixed/, NORMS, TODO, READMEs, CHANGELOG.

Co-Authored-By: Claude Opus 5.5 <noreply@anthropic.com>
Claude-Session: https://claude.ai/code/session_01NEaWSMCoGDPkcQwasoKLW3
</commit_message>
<xml_diff>
--- a/excel_ai/CPAT-AI_Overview_latest.pptx
+++ b/excel_ai/CPAT-AI_Overview_latest.pptx
@@ -123,7 +123,7 @@
   <p:extLst>
     <p:ext uri="{521415D9-36F7-43E2-AB2F-B90AF26B5E84}">
       <p14:sectionLst xmlns:p14="http://schemas.microsoft.com/office/powerpoint/2010/main">
-        <p14:section name="Overview" id="{90e6b3ea-2b1a-8adc-9642-76b805d07b72}">
+        <p14:section name="Overview" id="{419f64cd-9d0e-0cbe-fe9e-3f5f8f7f6491}">
           <p14:sldIdLst>
             <p14:sldId id="256"/>
             <p14:sldId id="257"/>
@@ -132,14 +132,14 @@
             <p14:sldId id="260"/>
           </p14:sldIdLst>
         </p14:section>
-        <p14:section name="Using the workbook" id="{ba0ec29b-1fb6-bd32-b833-4f1fbdf95fa7}">
+        <p14:section name="Using the workbook" id="{84ad9f2b-53c8-b933-fa46-729d12d4f225}">
           <p14:sldIdLst>
             <p14:sldId id="261"/>
             <p14:sldId id="262"/>
             <p14:sldId id="263"/>
           </p14:sldIdLst>
         </p14:section>
-        <p14:section name="Model and results" id="{154d109d-1542-782a-04e5-193074b8bdc2}">
+        <p14:section name="Model and results" id="{5136f9cf-e9fe-0481-59e8-988a960f11ce}">
           <p14:sldIdLst>
             <p14:sldId id="264"/>
             <p14:sldId id="265"/>
@@ -151,7 +151,7 @@
             <p14:sldId id="271"/>
           </p14:sldIdLst>
         </p14:section>
-        <p14:section name="Next steps" id="{69b4a7f5-49b4-f4f8-a186-e8eeede790e4}">
+        <p14:section name="Next steps" id="{553201fb-5db3-d452-df84-2ba4f96f7096}">
           <p14:sldIdLst>
             <p14:sldId id="272"/>
           </p14:sldIdLst>
@@ -5584,7 +5584,7 @@
           <a:p>
             <a:r>
               <a:rPr lang="en-US" dirty="0"/>
-              <a:t>Distribution tab, scenario group 2. Gini change with recycling: -1.54%. Eleven charts on the tab. Method: Distribution_Method.md.</a:t>
+              <a:t>Distribution tab, scenario group 2. Gini change with recycling: -1.54%. Eleven charts on the tab. Method: Methods, chapter Distribution.</a:t>
             </a:r>
             <a:endParaRPr lang="en-US" dirty="0"/>
           </a:p>
@@ -5760,7 +5760,7 @@
           <a:p>
             <a:r>
               <a:rPr lang="en-US" dirty="0"/>
-              <a:t>Quick check check_quick_report_v8.0.md: PASS. Full check check_report_v8.0.md: Overall: PASS**.</a:t>
+              <a:t>Quick check check_quick_report_v8.2.md: PASS. Full check check_report_v8.2.md: Overall: PASS** (sections 0-13 in the full run; section 14 rerun).</a:t>
             </a:r>
             <a:endParaRPr lang="en-US" dirty="0"/>
           </a:p>
@@ -5848,7 +5848,7 @@
           <a:p>
             <a:r>
               <a:rPr lang="en-US" dirty="0"/>
-              <a:t>Files: CPAT-AI-Mitigation-Prototype-v8.0.xlsm (repository root), QuickStart.md, documentation/CPAT-AI_BugsAndIssues_v7.2.docx. Also open: reconcile with legacy file 459 (U2); ETS goal seek user test (I30). Open items from issues_register.py; I52 and I53 wait for features not planned.</a:t>
+              <a:t>Files: CPAT-AI-Mitigation-Prototype-v8.2.xlsm (repository root), the Documentation, CPAT-AI_BugsAndIssues_v7.2.docx. Also open: the numerical check on the latest legacy file, 465 (U2); ETS goal seek user test (I30). Open items from issues_register.py; I52 and I53 wait for features not planned.</a:t>
             </a:r>
             <a:endParaRPr lang="en-US" dirty="0"/>
           </a:p>
@@ -6836,7 +6836,7 @@
                   <a:srgbClr val="5C667A"/>
                 </a:solidFill>
               </a:rPr>
-              <a:t>CPAT-AI-Mitigation-Prototype v8.0  ·  core deck  ·  screenshots and charts from the workbook</a:t>
+              <a:t>CPAT-AI-Mitigation-Prototype v8.2  ·  core deck  ·  screenshots and charts from the workbook</a:t>
             </a:r>
             <a:endParaRPr lang="en-US" sz="900" dirty="0"/>
           </a:p>
@@ -7568,7 +7568,7 @@
                   <a:srgbClr val="CADCFC"/>
                 </a:solidFill>
               </a:rPr>
-              <a:t>Version 8.0, October 2026  ·  Egypt data  ·  prototype for discussion</a:t>
+              <a:t>Version 8.2, October 2026  ·  Egypt data  ·  prototype for discussion</a:t>
             </a:r>
             <a:endParaRPr lang="en-US" sz="1000" dirty="0"/>
           </a:p>
@@ -7608,7 +7608,7 @@
       </p:sp>
       <p:pic>
         <p:nvPicPr>
-          <p:cNvPr id="13" name="screenshot-11" descr="/home/user/cpat-ai/excel_ai/mitigation/presentation/img/v80_01_overview.png">    </p:cNvPr>
+          <p:cNvPr id="13" name="screenshot-11" descr="/home/user/CPAT-AI/excel_ai/mitigation/presentation/img/v82_01_overview.png">    </p:cNvPr>
           <p:cNvPicPr>
             <a:picLocks noChangeAspect="1"/>
           </p:cNvPicPr>
@@ -8733,7 +8733,7 @@
       </p:sp>
       <p:pic>
         <p:nvPicPr>
-          <p:cNvPr id="7" name="screenshot-138" descr="/home/user/cpat-ai/excel_ai/mitigation/presentation/img/v80_03_power.png">    </p:cNvPr>
+          <p:cNvPr id="7" name="screenshot-138" descr="/home/user/CPAT-AI/excel_ai/mitigation/presentation/img/v82_03_power.png">    </p:cNvPr>
           <p:cNvPicPr>
             <a:picLocks noChangeAspect="1"/>
           </p:cNvPicPr>
@@ -9641,7 +9641,7 @@
                   <a:srgbClr val="5C667A"/>
                 </a:solidFill>
               </a:rPr>
-              <a:t>The road bugs: register section 3.2 (CPAT-AI_BugsAndIssues_v7.2.docx); method: Transport_Method.md.</a:t>
+              <a:t>The road bugs: register section 3.2 (CPAT-AI_BugsAndIssues_v7.2.docx); method: Methods, chapter Transport.</a:t>
             </a:r>
             <a:endParaRPr lang="en-US" sz="1200" dirty="0"/>
           </a:p>
@@ -10963,7 +10963,7 @@
                   <a:srgbClr val="5C667A"/>
                 </a:solidFill>
               </a:rPr>
-              <a:t>Method: ResultsSections_Method.md. Every new row is recomputed in Python in every scenario.</a:t>
+              <a:t>Method: Methods, chapter Macro and results. Every new row is recomputed in Python in every scenario.</a:t>
             </a:r>
             <a:endParaRPr lang="en-US" sz="1200" dirty="0"/>
           </a:p>
@@ -11207,7 +11207,7 @@
                 <a:ea typeface="Cambria" pitchFamily="34" charset="-122"/>
                 <a:cs typeface="Cambria" pitchFamily="34" charset="-120"/>
               </a:rPr>
-              <a:t>399,839</a:t>
+              <a:t>408,711</a:t>
             </a:r>
             <a:endParaRPr lang="en-US" sz="4000" dirty="0"/>
           </a:p>
@@ -13287,7 +13287,7 @@
                   <a:srgbClr val="5C667A"/>
                 </a:solidFill>
               </a:rPr>
-              <a:t>Source: CPAT-AI repo, release 8.0 and the bug and issue register (CPAT-AI_BugsAndIssues_v7.2.docx).</a:t>
+              <a:t>Source: CPAT-AI repo, release 8.2 and the bug and issue register (CPAT-AI_BugsAndIssues_v7.2.docx).</a:t>
             </a:r>
             <a:endParaRPr lang="en-US" sz="1200" dirty="0"/>
           </a:p>
@@ -16017,7 +16017,7 @@
                   <a:srgbClr val="5C667A"/>
                 </a:solidFill>
               </a:rPr>
-              <a:t>131 mitigation and 31 distribution bugs, all fixed in the prototype; also 63 legacy issues (53 mitigation, 10 distribution), replicated and tracked. Fix plans: CPAT-AI_BugsAndIssues_v7.2.docx.</a:t>
+              <a:t>131 mitigation and 31 distribution bugs, all fixed in the prototype; also 63 legacy issues (53 mitigation, 10 distribution), replicated and tracked. Fix plans: CPAT-AI_BugsAndIssues_v7.2.docx. Legacy CPAT 1.0pre_465: the CPAT team marked 62 fixed (52 confirmed, 8 with caveats, 2 not fixed).</a:t>
             </a:r>
             <a:endParaRPr lang="en-US" sz="1200" dirty="0"/>
           </a:p>
@@ -17021,7 +17021,7 @@
       </p:sp>
       <p:pic>
         <p:nvPicPr>
-          <p:cNvPr id="5" name="screenshot-79" descr="/home/user/cpat-ai/excel_ai/mitigation/presentation/img/v80_01b_scenarios.png">    </p:cNvPr>
+          <p:cNvPr id="5" name="screenshot-79" descr="/home/user/CPAT-AI/excel_ai/mitigation/presentation/img/v82_01b_scenarios.png">    </p:cNvPr>
           <p:cNvPicPr>
             <a:picLocks noChangeAspect="1"/>
           </p:cNvPicPr>
@@ -17223,7 +17223,7 @@
                   <a:srgbClr val="1F1F2E"/>
                 </a:solidFill>
               </a:rPr>
-              <a:t>The same formula in every row of a block; all 399,839 formulas are short.</a:t>
+              <a:t>The same formula in every row of a block; all 408,711 formulas are short.</a:t>
             </a:r>
             <a:endParaRPr lang="en-US" sz="1500" dirty="0"/>
           </a:p>
@@ -17817,7 +17817,7 @@
       </p:sp>
       <p:pic>
         <p:nvPicPr>
-          <p:cNvPr id="16" name="screenshot-99" descr="/home/user/cpat-ai/excel_ai/mitigation/presentation/img/v80_06_definitions.png">    </p:cNvPr>
+          <p:cNvPr id="16" name="screenshot-99" descr="/home/user/CPAT-AI/excel_ai/mitigation/presentation/img/v82_06_definitions.png">    </p:cNvPr>
           <p:cNvPicPr>
             <a:picLocks noChangeAspect="1"/>
           </p:cNvPicPr>
@@ -17909,7 +17909,7 @@
       </p:sp>
       <p:pic>
         <p:nvPicPr>
-          <p:cNvPr id="19" name="screenshot-102" descr="/home/user/cpat-ai/excel_ai/mitigation/presentation/img/v80_05_compare.png">    </p:cNvPr>
+          <p:cNvPr id="19" name="screenshot-102" descr="/home/user/CPAT-AI/excel_ai/mitigation/presentation/img/v82_05_compare.png">    </p:cNvPr>
           <p:cNvPicPr>
             <a:picLocks noChangeAspect="1"/>
           </p:cNvPicPr>

</xml_diff>

<commit_message>
v8.3: to-do leftovers; legacy bug L134 fixed in the prototype
TODO tidy (CPAT-team items merged, coded/TODO names); register spreadsheet
built from the register itself (identical table); excel_lint.check() after
every save of every Excel writer; leads closed (Manual inputs J178:J179 are
read; NOx forcing explained by the fixed L22/L23/L58/L59); new legacy bug
L134 (price-increase unit labels) fixed in ScenarioDefinition. Release v8.3:
quick check 0 change vs v8.2, paste test PASS; documents, tracker and deck
regenerated.

Co-Authored-By: Claude Opus 5.5 <noreply@anthropic.com>
Claude-Session: https://claude.ai/code/session_01NEaWSMCoGDPkcQwasoKLW3
</commit_message>
<xml_diff>
--- a/excel_ai/CPAT-AI_Overview_latest.pptx
+++ b/excel_ai/CPAT-AI_Overview_latest.pptx
@@ -123,7 +123,7 @@
   <p:extLst>
     <p:ext uri="{521415D9-36F7-43E2-AB2F-B90AF26B5E84}">
       <p14:sectionLst xmlns:p14="http://schemas.microsoft.com/office/powerpoint/2010/main">
-        <p14:section name="Overview" id="{419f64cd-9d0e-0cbe-fe9e-3f5f8f7f6491}">
+        <p14:section name="Overview" id="{d93e811c-6e0d-9968-7972-b350d632f8ea}">
           <p14:sldIdLst>
             <p14:sldId id="256"/>
             <p14:sldId id="257"/>
@@ -132,14 +132,14 @@
             <p14:sldId id="260"/>
           </p14:sldIdLst>
         </p14:section>
-        <p14:section name="Using the workbook" id="{84ad9f2b-53c8-b933-fa46-729d12d4f225}">
+        <p14:section name="Using the workbook" id="{813f37cd-c743-ffe7-45a9-04672e1d5d2a}">
           <p14:sldIdLst>
             <p14:sldId id="261"/>
             <p14:sldId id="262"/>
             <p14:sldId id="263"/>
           </p14:sldIdLst>
         </p14:section>
-        <p14:section name="Model and results" id="{5136f9cf-e9fe-0481-59e8-988a960f11ce}">
+        <p14:section name="Model and results" id="{f73c5da9-4b53-b5f0-48a0-1b1a7db86587}">
           <p14:sldIdLst>
             <p14:sldId id="264"/>
             <p14:sldId id="265"/>
@@ -151,7 +151,7 @@
             <p14:sldId id="271"/>
           </p14:sldIdLst>
         </p14:section>
-        <p14:section name="Next steps" id="{553201fb-5db3-d452-df84-2ba4f96f7096}">
+        <p14:section name="Next steps" id="{3ed5ec9d-f008-fcee-ad03-182d177bca35}">
           <p14:sldIdLst>
             <p14:sldId id="272"/>
           </p14:sldIdLst>
@@ -5760,7 +5760,7 @@
           <a:p>
             <a:r>
               <a:rPr lang="en-US" dirty="0"/>
-              <a:t>Quick check check_quick_report_v8.2.md: PASS. Full check check_report_v8.2.md: Overall: PASS** (sections 0-13 in the full run; section 14 rerun).</a:t>
+              <a:t>Quick check check_quick_report_v8.3.md: PASS. Full check check_report_v8.3.md: Overall: PASS** (sections 0-13 in the full run; section 14 rerun).</a:t>
             </a:r>
             <a:endParaRPr lang="en-US" dirty="0"/>
           </a:p>
@@ -5848,7 +5848,7 @@
           <a:p>
             <a:r>
               <a:rPr lang="en-US" dirty="0"/>
-              <a:t>Files: CPAT-AI-Mitigation-Prototype-v8.2.xlsm (repository root), the Documentation, CPAT-AI_BugsAndIssues_v7.2.docx. Also open: the numerical check on the latest legacy file, 465 (U2); ETS goal seek user test (I30). Open items from issues_register.py; I52 and I53 wait for features not planned.</a:t>
+              <a:t>Files: CPAT-AI-Mitigation-Prototype-v8.3.xlsm (repository root), the Documentation, CPAT-AI_BugsAndIssues_v7.2.docx. Also open: the numerical check on the latest legacy file, 465 (U2); ETS goal seek user test (I30). Open items from issues_register.py; I52 and I53 wait for features not planned.</a:t>
             </a:r>
             <a:endParaRPr lang="en-US" dirty="0"/>
           </a:p>
@@ -6836,7 +6836,7 @@
                   <a:srgbClr val="5C667A"/>
                 </a:solidFill>
               </a:rPr>
-              <a:t>CPAT-AI-Mitigation-Prototype v8.2  ·  core deck  ·  screenshots and charts from the workbook</a:t>
+              <a:t>CPAT-AI-Mitigation-Prototype v8.3  ·  core deck  ·  screenshots and charts from the workbook</a:t>
             </a:r>
             <a:endParaRPr lang="en-US" sz="900" dirty="0"/>
           </a:p>
@@ -7532,7 +7532,7 @@
                   <a:srgbClr val="FFFFFF"/>
                 </a:solidFill>
               </a:rPr>
-              <a:t>162 legacy bugs found</a:t>
+              <a:t>163 legacy bugs found</a:t>
             </a:r>
             <a:endParaRPr lang="en-US" sz="1300" dirty="0"/>
           </a:p>
@@ -7568,7 +7568,7 @@
                   <a:srgbClr val="CADCFC"/>
                 </a:solidFill>
               </a:rPr>
-              <a:t>Version 8.2, October 2026  ·  Egypt data  ·  prototype for discussion</a:t>
+              <a:t>Version 8.3, October 2026  ·  Egypt data  ·  prototype for discussion</a:t>
             </a:r>
             <a:endParaRPr lang="en-US" sz="1000" dirty="0"/>
           </a:p>
@@ -7608,7 +7608,7 @@
       </p:sp>
       <p:pic>
         <p:nvPicPr>
-          <p:cNvPr id="13" name="screenshot-11" descr="/home/user/CPAT-AI/excel_ai/mitigation/presentation/img/v82_01_overview.png">    </p:cNvPr>
+          <p:cNvPr id="13" name="screenshot-11" descr="/home/user/CPAT-AI/excel_ai/mitigation/presentation/img/v83_01_overview.png">    </p:cNvPr>
           <p:cNvPicPr>
             <a:picLocks noChangeAspect="1"/>
           </p:cNvPicPr>
@@ -8733,7 +8733,7 @@
       </p:sp>
       <p:pic>
         <p:nvPicPr>
-          <p:cNvPr id="7" name="screenshot-138" descr="/home/user/CPAT-AI/excel_ai/mitigation/presentation/img/v82_03_power.png">    </p:cNvPr>
+          <p:cNvPr id="7" name="screenshot-138" descr="/home/user/CPAT-AI/excel_ai/mitigation/presentation/img/v83_03_power.png">    </p:cNvPr>
           <p:cNvPicPr>
             <a:picLocks noChangeAspect="1"/>
           </p:cNvPicPr>
@@ -11313,7 +11313,7 @@
                 <a:ea typeface="Cambria" pitchFamily="34" charset="-122"/>
                 <a:cs typeface="Cambria" pitchFamily="34" charset="-120"/>
               </a:rPr>
-              <a:t>162</a:t>
+              <a:t>163</a:t>
             </a:r>
             <a:endParaRPr lang="en-US" sz="4000" dirty="0"/>
           </a:p>
@@ -13131,7 +13131,7 @@
                 <a:ea typeface="Cambria" pitchFamily="34" charset="-122"/>
                 <a:cs typeface="Cambria" pitchFamily="34" charset="-120"/>
               </a:rPr>
-              <a:t>162</a:t>
+              <a:t>163</a:t>
             </a:r>
             <a:endParaRPr lang="en-US" sz="4000" dirty="0"/>
           </a:p>
@@ -13145,7 +13145,7 @@
                   <a:srgbClr val="5C667A"/>
                 </a:solidFill>
               </a:rPr>
-              <a:t>legacy bugs found (131 mitigation, 31 distribution), none replicated</a:t>
+              <a:t>legacy bugs found (132 mitigation, 31 distribution), none replicated</a:t>
             </a:r>
             <a:endParaRPr lang="en-US" sz="4000" dirty="0"/>
           </a:p>
@@ -13287,7 +13287,7 @@
                   <a:srgbClr val="5C667A"/>
                 </a:solidFill>
               </a:rPr>
-              <a:t>Source: CPAT-AI repo, release 8.2 and the bug and issue register (CPAT-AI_BugsAndIssues_v7.2.docx).</a:t>
+              <a:t>Source: CPAT-AI repo, release 8.3 and the bug and issue register (CPAT-AI_BugsAndIssues_v7.2.docx).</a:t>
             </a:r>
             <a:endParaRPr lang="en-US" sz="1200" dirty="0"/>
           </a:p>
@@ -14606,7 +14606,7 @@
                 <a:ea typeface="Cambria" pitchFamily="34" charset="-122"/>
                 <a:cs typeface="Cambria" pitchFamily="34" charset="-120"/>
               </a:rPr>
-              <a:t>162 bugs found in legacy CPAT; 9 change today's results</a:t>
+              <a:t>163 bugs found in legacy CPAT; 9 change today's results</a:t>
             </a:r>
             <a:endParaRPr lang="en-US" sz="3000" dirty="0"/>
           </a:p>
@@ -15967,7 +15967,7 @@
                 <a:ea typeface="Cambria" pitchFamily="34" charset="-122"/>
                 <a:cs typeface="Cambria" pitchFamily="34" charset="-120"/>
               </a:rPr>
-              <a:t>79 + 31</a:t>
+              <a:t>80 + 31</a:t>
             </a:r>
             <a:endParaRPr lang="en-US" sz="4000" dirty="0"/>
           </a:p>
@@ -16017,7 +16017,7 @@
                   <a:srgbClr val="5C667A"/>
                 </a:solidFill>
               </a:rPr>
-              <a:t>131 mitigation and 31 distribution bugs, all fixed in the prototype; also 63 legacy issues (53 mitigation, 10 distribution), replicated and tracked. Fix plans: CPAT-AI_BugsAndIssues_v7.2.docx. Legacy CPAT 1.0pre_465: the CPAT team marked 62 fixed (52 confirmed, 8 with caveats, 2 not fixed).</a:t>
+              <a:t>132 mitigation and 31 distribution bugs, all fixed in the prototype; also 63 legacy issues (53 mitigation, 10 distribution), replicated and tracked. Fix plans: CPAT-AI_BugsAndIssues_v7.2.docx. Legacy CPAT 1.0pre_465: the CPAT team marked 62 fixed (52 confirmed, 8 with caveats, 2 not fixed).</a:t>
             </a:r>
             <a:endParaRPr lang="en-US" sz="1200" dirty="0"/>
           </a:p>
@@ -17021,7 +17021,7 @@
       </p:sp>
       <p:pic>
         <p:nvPicPr>
-          <p:cNvPr id="5" name="screenshot-79" descr="/home/user/CPAT-AI/excel_ai/mitigation/presentation/img/v82_01b_scenarios.png">    </p:cNvPr>
+          <p:cNvPr id="5" name="screenshot-79" descr="/home/user/CPAT-AI/excel_ai/mitigation/presentation/img/v83_01b_scenarios.png">    </p:cNvPr>
           <p:cNvPicPr>
             <a:picLocks noChangeAspect="1"/>
           </p:cNvPicPr>
@@ -17817,7 +17817,7 @@
       </p:sp>
       <p:pic>
         <p:nvPicPr>
-          <p:cNvPr id="16" name="screenshot-99" descr="/home/user/CPAT-AI/excel_ai/mitigation/presentation/img/v82_06_definitions.png">    </p:cNvPr>
+          <p:cNvPr id="16" name="screenshot-99" descr="/home/user/CPAT-AI/excel_ai/mitigation/presentation/img/v83_06_definitions.png">    </p:cNvPr>
           <p:cNvPicPr>
             <a:picLocks noChangeAspect="1"/>
           </p:cNvPicPr>
@@ -17909,7 +17909,7 @@
       </p:sp>
       <p:pic>
         <p:nvPicPr>
-          <p:cNvPr id="19" name="screenshot-102" descr="/home/user/CPAT-AI/excel_ai/mitigation/presentation/img/v82_05_compare.png">    </p:cNvPr>
+          <p:cNvPr id="19" name="screenshot-102" descr="/home/user/CPAT-AI/excel_ai/mitigation/presentation/img/v83_05_compare.png">    </p:cNvPr>
           <p:cNvPicPr>
             <a:picLocks noChangeAspect="1"/>
           </p:cNvPicPr>

</xml_diff>